<commit_message>
feat: added priceTotal to BookingConfirmation
</commit_message>
<xml_diff>
--- a/Presentazione Progetto.pptx
+++ b/Presentazione Progetto.pptx
@@ -16,7 +16,7 @@
     <p:sldId id="264" r:id="rId10"/>
   </p:sldIdLst>
   <p:sldSz cx="12192000" cy="6858000"/>
-  <p:notesSz cx="6858000" cy="9144000"/>
+  <p:notesSz cx="7099300" cy="10234613"/>
   <p:defaultTextStyle>
     <a:defPPr>
       <a:defRPr lang="it-IT"/>
@@ -112,6 +112,11 @@
       </a:defRPr>
     </a:lvl9pPr>
   </p:defaultTextStyle>
+  <p:extLst>
+    <p:ext uri="{EFAFB233-063F-42B5-8137-9DF3F51BA10A}">
+      <p15:sldGuideLst xmlns:p15="http://schemas.microsoft.com/office/powerpoint/2012/main"/>
+    </p:ext>
+  </p:extLst>
 </p:presentation>
 </file>
 
@@ -3433,8 +3438,17 @@
             </a:br>
             <a:r>
               <a:rPr lang="en-US" dirty="0"/>
-              <a:t> https://github.com/StatJon/Progetto-IngegneriaSistemiWeb.git</a:t>
-            </a:r>
+              <a:t> </a:t>
+            </a:r>
+            <a:r>
+              <a:rPr lang="en-US" dirty="0">
+                <a:hlinkClick r:id="rId4"/>
+              </a:rPr>
+              <a:t>https://github.com/StatJon/Progetto-IngegneriaSistemiWeb.git</a:t>
+            </a:r>
+            <a:endParaRPr lang="en-US" dirty="0"/>
+          </a:p>
+          <a:p>
             <a:endParaRPr lang="it-IT" dirty="0"/>
           </a:p>
           <a:p>
@@ -3835,7 +3849,7 @@
         <p:spPr/>
         <p:txBody>
           <a:bodyPr>
-            <a:normAutofit fontScale="92500" lnSpcReduction="20000"/>
+            <a:normAutofit fontScale="85000" lnSpcReduction="20000"/>
           </a:bodyPr>
           <a:lstStyle/>
           <a:p>
@@ -3855,13 +3869,13 @@
             </a:r>
             <a:r>
               <a:rPr lang="it-IT" dirty="0"/>
-              <a:t> ed homepage.</a:t>
+              <a:t>, homepage e pagina utente.</a:t>
             </a:r>
           </a:p>
           <a:p>
             <a:r>
               <a:rPr lang="it-IT" dirty="0"/>
-              <a:t>Successivamente è necessario scegliere quali servizi effettuare ed infine inserire i dettagli del veicolo e decidere la data e l’ora dell’appuntamento.</a:t>
+              <a:t>Successivamente è necessario scegliere quali servizi effettuare ed infine inserire i dettagli del veicolo e decidere la data e l’ora dell’appuntamento, vengono mostrati i giorni e gli orari disponibili in base alla disponibilità di meccanici a quell’ora-giorno.</a:t>
             </a:r>
           </a:p>
           <a:p>

</xml_diff>